<commit_message>
6장 수업 1, 2, 5, 8(1, 2, 8 해야 함)
</commit_message>
<xml_diff>
--- a/문제해결프로그래밍_숙제/제출용/숙제6_2022182035.pptx
+++ b/문제해결프로그래밍_숙제/제출용/숙제6_2022182035.pptx
@@ -34500,23 +34500,83 @@
           </a:bodyPr>
           <a:lstStyle/>
           <a:p>
-            <a:pPr marL="50800" lvl="0" algn="ctr" rtl="0">
-              <a:spcBef>
-                <a:spcPts val="0"/>
-              </a:spcBef>
-              <a:spcAft>
-                <a:spcPts val="0"/>
-              </a:spcAft>
-              <a:buSzPts val="2800"/>
-            </a:pPr>
+            <a:pPr marL="50800" lvl="0"/>
             <a:r>
               <a:rPr lang="en-US" dirty="0"/>
               <a:t>5. </a:t>
+            </a:r>
+            <a:r>
+              <a:rPr lang="ko-KR" altLang="en-US" dirty="0"/>
+              <a:t>도둑질 </a:t>
+            </a:r>
+            <a:r>
+              <a:rPr lang="en-US" altLang="ko-KR" dirty="0"/>
+              <a:t>(Programmers, DP) </a:t>
             </a:r>
             <a:endParaRPr dirty="0"/>
           </a:p>
         </p:txBody>
       </p:sp>
+      <p:pic>
+        <p:nvPicPr>
+          <p:cNvPr id="3" name="그림 2">
+            <a:extLst>
+              <a:ext uri="{FF2B5EF4-FFF2-40B4-BE49-F238E27FC236}">
+                <a16:creationId xmlns:a16="http://schemas.microsoft.com/office/drawing/2014/main" id="{7DF8B7D5-B490-EAA7-693D-B0E0EA5953EC}"/>
+              </a:ext>
+            </a:extLst>
+          </p:cNvPr>
+          <p:cNvPicPr>
+            <a:picLocks noChangeAspect="1"/>
+          </p:cNvPicPr>
+          <p:nvPr/>
+        </p:nvPicPr>
+        <p:blipFill>
+          <a:blip r:embed="rId3"/>
+          <a:stretch>
+            <a:fillRect/>
+          </a:stretch>
+        </p:blipFill>
+        <p:spPr>
+          <a:xfrm>
+            <a:off x="5025295" y="1142996"/>
+            <a:ext cx="1955007" cy="3233057"/>
+          </a:xfrm>
+          <a:prstGeom prst="rect">
+            <a:avLst/>
+          </a:prstGeom>
+        </p:spPr>
+      </p:pic>
+      <p:pic>
+        <p:nvPicPr>
+          <p:cNvPr id="5" name="그림 4">
+            <a:extLst>
+              <a:ext uri="{FF2B5EF4-FFF2-40B4-BE49-F238E27FC236}">
+                <a16:creationId xmlns:a16="http://schemas.microsoft.com/office/drawing/2014/main" id="{B93E40DD-5738-5C8B-722F-5202A42F2780}"/>
+              </a:ext>
+            </a:extLst>
+          </p:cNvPr>
+          <p:cNvPicPr>
+            <a:picLocks noChangeAspect="1"/>
+          </p:cNvPicPr>
+          <p:nvPr/>
+        </p:nvPicPr>
+        <p:blipFill>
+          <a:blip r:embed="rId4"/>
+          <a:stretch>
+            <a:fillRect/>
+          </a:stretch>
+        </p:blipFill>
+        <p:spPr>
+          <a:xfrm>
+            <a:off x="1067664" y="1114250"/>
+            <a:ext cx="3430846" cy="3290551"/>
+          </a:xfrm>
+          <a:prstGeom prst="rect">
+            <a:avLst/>
+          </a:prstGeom>
+        </p:spPr>
+      </p:pic>
     </p:spTree>
     <p:extLst>
       <p:ext uri="{BB962C8B-B14F-4D97-AF65-F5344CB8AC3E}">

</xml_diff>